<commit_message>
feat: add prominent Team ATOMIX badge on Slide 1 and update deck branding
</commit_message>
<xml_diff>
--- a/NutriWise_Hackday_Presentation.pptx
+++ b/NutriWise_Hackday_Presentation.pptx
@@ -3147,7 +3147,73 @@
       </p:sp>
       <p:sp>
         <p:nvSpPr>
-          <p:cNvPr id="3" name="TextBox 2"/>
+          <p:cNvPr id="3" name="Rounded Rectangle 2"/>
+          <p:cNvSpPr/>
+          <p:nvPr/>
+        </p:nvSpPr>
+        <p:spPr>
+          <a:xfrm>
+            <a:off x="9281160" y="292608"/>
+            <a:ext cx="2304288" cy="621792"/>
+          </a:xfrm>
+          <a:prstGeom prst="roundRect">
+            <a:avLst/>
+          </a:prstGeom>
+          <a:solidFill>
+            <a:srgbClr val="0F2E22"/>
+          </a:solidFill>
+          <a:ln w="19050">
+            <a:solidFill>
+              <a:srgbClr val="EA580C"/>
+            </a:solidFill>
+          </a:ln>
+        </p:spPr>
+        <p:style>
+          <a:lnRef idx="1">
+            <a:schemeClr val="accent1"/>
+          </a:lnRef>
+          <a:fillRef idx="3">
+            <a:schemeClr val="accent1"/>
+          </a:fillRef>
+          <a:effectRef idx="2">
+            <a:schemeClr val="accent1"/>
+          </a:effectRef>
+          <a:fontRef idx="minor">
+            <a:schemeClr val="lt1"/>
+          </a:fontRef>
+        </p:style>
+        <p:txBody>
+          <a:bodyPr rtlCol="0" anchor="ctr" wrap="square" lIns="0" rIns="0" tIns="0" bIns="0"/>
+          <a:lstStyle/>
+          <a:p>
+            <a:pPr algn="ctr">
+              <a:defRPr sz="850" b="1">
+                <a:solidFill>
+                  <a:srgbClr val="EA580C"/>
+                </a:solidFill>
+              </a:defRPr>
+            </a:pPr>
+            <a:r>
+              <a:t>⚡ TEAM NAME</a:t>
+            </a:r>
+          </a:p>
+          <a:p>
+            <a:pPr algn="ctr">
+              <a:defRPr sz="1600" b="1">
+                <a:solidFill>
+                  <a:srgbClr val="FFFFFF"/>
+                </a:solidFill>
+              </a:defRPr>
+            </a:pPr>
+            <a:r>
+              <a:t>ATOMIX</a:t>
+            </a:r>
+          </a:p>
+        </p:txBody>
+      </p:sp>
+      <p:sp>
+        <p:nvSpPr>
+          <p:cNvPr id="4" name="TextBox 3"/>
           <p:cNvSpPr txBox="1"/>
           <p:nvPr/>
         </p:nvSpPr>
@@ -3178,7 +3244,7 @@
               </a:defRPr>
             </a:pPr>
             <a:r>
-              <a:t>1️⃣  PROBLEM STATEMENT</a:t>
+              <a:t>TEAM ATOMIX  |  1️⃣  PROBLEM STATEMENT</a:t>
             </a:r>
           </a:p>
           <a:p>
@@ -3209,7 +3275,7 @@
       </p:sp>
       <p:sp>
         <p:nvSpPr>
-          <p:cNvPr id="4" name="TextBox 3"/>
+          <p:cNvPr id="5" name="TextBox 4"/>
           <p:cNvSpPr txBox="1"/>
           <p:nvPr/>
         </p:nvSpPr>
@@ -3237,14 +3303,14 @@
               </a:defRPr>
             </a:pPr>
             <a:r>
-              <a:t>NutriWise  |  Team DECODEP  |  Hackday 1.0 Final Submission                                                                   Slide 1 of 7</a:t>
-            </a:r>
-          </a:p>
-        </p:txBody>
-      </p:sp>
-      <p:sp>
-        <p:nvSpPr>
-          <p:cNvPr id="5" name="Rounded Rectangle 4"/>
+              <a:t>NutriWise  |  Team ATOMIX  |  Hackday 1.0 Final Submission                                                                   Slide 1 of 7</a:t>
+            </a:r>
+          </a:p>
+        </p:txBody>
+      </p:sp>
+      <p:sp>
+        <p:nvSpPr>
+          <p:cNvPr id="6" name="Rounded Rectangle 5"/>
           <p:cNvSpPr/>
           <p:nvPr/>
         </p:nvSpPr>
@@ -3289,7 +3355,7 @@
       </p:sp>
       <p:sp>
         <p:nvSpPr>
-          <p:cNvPr id="6" name="TextBox 5"/>
+          <p:cNvPr id="7" name="TextBox 6"/>
           <p:cNvSpPr txBox="1"/>
           <p:nvPr/>
         </p:nvSpPr>
@@ -3419,7 +3485,7 @@
       </p:sp>
       <p:sp>
         <p:nvSpPr>
-          <p:cNvPr id="7" name="Rounded Rectangle 6"/>
+          <p:cNvPr id="8" name="Rounded Rectangle 7"/>
           <p:cNvSpPr/>
           <p:nvPr/>
         </p:nvSpPr>
@@ -3471,7 +3537,7 @@
       </p:sp>
       <p:sp>
         <p:nvSpPr>
-          <p:cNvPr id="8" name="Rounded Rectangle 7"/>
+          <p:cNvPr id="9" name="Rounded Rectangle 8"/>
           <p:cNvSpPr/>
           <p:nvPr/>
         </p:nvSpPr>
@@ -3516,7 +3582,7 @@
       </p:sp>
       <p:sp>
         <p:nvSpPr>
-          <p:cNvPr id="9" name="TextBox 8"/>
+          <p:cNvPr id="10" name="TextBox 9"/>
           <p:cNvSpPr txBox="1"/>
           <p:nvPr/>
         </p:nvSpPr>
@@ -3646,7 +3712,7 @@
       </p:sp>
       <p:sp>
         <p:nvSpPr>
-          <p:cNvPr id="10" name="Rounded Rectangle 9"/>
+          <p:cNvPr id="11" name="Rounded Rectangle 10"/>
           <p:cNvSpPr/>
           <p:nvPr/>
         </p:nvSpPr>
@@ -3698,7 +3764,7 @@
       </p:sp>
       <p:sp>
         <p:nvSpPr>
-          <p:cNvPr id="11" name="Rounded Rectangle 10"/>
+          <p:cNvPr id="12" name="Rounded Rectangle 11"/>
           <p:cNvSpPr/>
           <p:nvPr/>
         </p:nvSpPr>
@@ -3743,7 +3809,7 @@
       </p:sp>
       <p:sp>
         <p:nvSpPr>
-          <p:cNvPr id="12" name="TextBox 11"/>
+          <p:cNvPr id="13" name="TextBox 12"/>
           <p:cNvSpPr txBox="1"/>
           <p:nvPr/>
         </p:nvSpPr>
@@ -3937,7 +4003,7 @@
               </a:defRPr>
             </a:pPr>
             <a:r>
-              <a:t>NutriWise  |  Team DECODEP  |  Hackday 1.0 Final Submission                                                                   Slide 2 of 7</a:t>
+              <a:t>NutriWise  |  Team ATOMIX  |  Hackday 1.0 Final Submission                                                                   Slide 2 of 7</a:t>
             </a:r>
           </a:p>
         </p:txBody>
@@ -5197,7 +5263,7 @@
               </a:defRPr>
             </a:pPr>
             <a:r>
-              <a:t>NutriWise  |  Team DECODEP  |  Hackday 1.0 Final Submission                                                                   Slide 3 of 7</a:t>
+              <a:t>NutriWise  |  Team ATOMIX  |  Hackday 1.0 Final Submission                                                                   Slide 3 of 7</a:t>
             </a:r>
           </a:p>
         </p:txBody>
@@ -6187,7 +6253,7 @@
               </a:defRPr>
             </a:pPr>
             <a:r>
-              <a:t>NutriWise  |  Team DECODEP  |  Hackday 1.0 Final Submission                                                                   Slide 4 of 7</a:t>
+              <a:t>NutriWise  |  Team ATOMIX  |  Hackday 1.0 Final Submission                                                                   Slide 4 of 7</a:t>
             </a:r>
           </a:p>
         </p:txBody>
@@ -7210,7 +7276,7 @@
               </a:defRPr>
             </a:pPr>
             <a:r>
-              <a:t>NutriWise  |  Team DECODEP  |  Hackday 1.0 Final Submission                                                                   Slide 5 of 7</a:t>
+              <a:t>NutriWise  |  Team ATOMIX  |  Hackday 1.0 Final Submission                                                                   Slide 5 of 7</a:t>
             </a:r>
           </a:p>
         </p:txBody>
@@ -8116,7 +8182,7 @@
               </a:defRPr>
             </a:pPr>
             <a:r>
-              <a:t>NutriWise  |  Team DECODEP  |  Hackday 1.0 Final Submission                                                                   Slide 6 of 7</a:t>
+              <a:t>NutriWise  |  Team ATOMIX  |  Hackday 1.0 Final Submission                                                                   Slide 6 of 7</a:t>
             </a:r>
           </a:p>
         </p:txBody>
@@ -9106,7 +9172,7 @@
               </a:defRPr>
             </a:pPr>
             <a:r>
-              <a:t>NutriWise  |  Team DECODEP  |  Hackday 1.0 Final Submission                                                                   Slide 7 of 7</a:t>
+              <a:t>NutriWise  |  Team ATOMIX  |  Hackday 1.0 Final Submission                                                                   Slide 7 of 7</a:t>
             </a:r>
           </a:p>
         </p:txBody>

</xml_diff>

<commit_message>
chore: remove 'Final Submission' wording from presentation footer
</commit_message>
<xml_diff>
--- a/NutriWise_Hackday_Presentation.pptx
+++ b/NutriWise_Hackday_Presentation.pptx
@@ -3303,7 +3303,7 @@
               </a:defRPr>
             </a:pPr>
             <a:r>
-              <a:t>NutriWise  |  Team ATOMIX  |  Hackday 1.0 Final Submission                                                                   Slide 1 of 7</a:t>
+              <a:t>NutriWise  |  Team ATOMIX  |  Hackday 1.0                                                                                  Slide 1 of 7</a:t>
             </a:r>
           </a:p>
         </p:txBody>
@@ -4003,7 +4003,7 @@
               </a:defRPr>
             </a:pPr>
             <a:r>
-              <a:t>NutriWise  |  Team ATOMIX  |  Hackday 1.0 Final Submission                                                                   Slide 2 of 7</a:t>
+              <a:t>NutriWise  |  Team ATOMIX  |  Hackday 1.0                                                                                  Slide 2 of 7</a:t>
             </a:r>
           </a:p>
         </p:txBody>
@@ -5263,7 +5263,7 @@
               </a:defRPr>
             </a:pPr>
             <a:r>
-              <a:t>NutriWise  |  Team ATOMIX  |  Hackday 1.0 Final Submission                                                                   Slide 3 of 7</a:t>
+              <a:t>NutriWise  |  Team ATOMIX  |  Hackday 1.0                                                                                  Slide 3 of 7</a:t>
             </a:r>
           </a:p>
         </p:txBody>
@@ -6253,7 +6253,7 @@
               </a:defRPr>
             </a:pPr>
             <a:r>
-              <a:t>NutriWise  |  Team ATOMIX  |  Hackday 1.0 Final Submission                                                                   Slide 4 of 7</a:t>
+              <a:t>NutriWise  |  Team ATOMIX  |  Hackday 1.0                                                                                  Slide 4 of 7</a:t>
             </a:r>
           </a:p>
         </p:txBody>
@@ -7276,7 +7276,7 @@
               </a:defRPr>
             </a:pPr>
             <a:r>
-              <a:t>NutriWise  |  Team ATOMIX  |  Hackday 1.0 Final Submission                                                                   Slide 5 of 7</a:t>
+              <a:t>NutriWise  |  Team ATOMIX  |  Hackday 1.0                                                                                  Slide 5 of 7</a:t>
             </a:r>
           </a:p>
         </p:txBody>
@@ -8182,7 +8182,7 @@
               </a:defRPr>
             </a:pPr>
             <a:r>
-              <a:t>NutriWise  |  Team ATOMIX  |  Hackday 1.0 Final Submission                                                                   Slide 6 of 7</a:t>
+              <a:t>NutriWise  |  Team ATOMIX  |  Hackday 1.0                                                                                  Slide 6 of 7</a:t>
             </a:r>
           </a:p>
         </p:txBody>
@@ -9172,7 +9172,7 @@
               </a:defRPr>
             </a:pPr>
             <a:r>
-              <a:t>NutriWise  |  Team ATOMIX  |  Hackday 1.0 Final Submission                                                                   Slide 7 of 7</a:t>
+              <a:t>NutriWise  |  Team ATOMIX  |  Hackday 1.0                                                                                  Slide 7 of 7</a:t>
             </a:r>
           </a:p>
         </p:txBody>

</xml_diff>